<commit_message>
feat(curriculum): reconcile classroom sources, import current worked examples, add worksheet work tools
- Import all 108 session worked examples from the current practice forms; fix commuting (four-week model) and bridge (1 lb ≈ 0.454 kg) tasks
- Add teacher slide decks and classroom-alignment reconciliation (validate:classroom-alignment)
- Worksheet work: typed reasoning, keyboard answer selection, optional hints, predict-before-reveal on existing Save/Resume
- Regenerate download manifest, catalog and test-reads

Game redesign work is parked on wip/game-transformation and is not part of this commit.

Claude-Session: https://claude.ai/code/session_0186Nm4mzU7oegGKh8oJQvR3
</commit_message>
<xml_diff>
--- a/lessons/3-2/slides.pptx
+++ b/lessons/3-2/slides.pptx
@@ -2334,7 +2334,7 @@
             <a:avLst/>
           </a:prstGeom>
           <a:solidFill>
-            <a:srgbClr val="B0883B">
+            <a:srgbClr val="C0654A">
               <a:alpha val="35000"/>
             </a:srgbClr>
           </a:solidFill>
@@ -2452,7 +2452,7 @@
                 <a:ea typeface="Outfit" pitchFamily="34" charset="-122"/>
                 <a:cs typeface="Outfit" pitchFamily="34" charset="-120"/>
               </a:rPr>
-              <a:t>Rates and Unit Rates</a:t>
+              <a:t>Understand Rates and Unit Rates</a:t>
             </a:r>
             <a:endParaRPr lang="en-US" sz="3000" dirty="0"/>
           </a:p>
@@ -2475,7 +2475,7 @@
             </a:avLst>
           </a:prstGeom>
           <a:solidFill>
-            <a:srgbClr val="B0883B"/>
+            <a:srgbClr val="C0654A"/>
           </a:solidFill>
           <a:ln/>
         </p:spPr>
@@ -2534,7 +2534,7 @@
                 <a:ea typeface="Hanken Grotesk" pitchFamily="34" charset="-122"/>
                 <a:cs typeface="Hanken Grotesk" pitchFamily="34" charset="-120"/>
               </a:rPr>
-              <a:t>Unit 4  ·  Lesson 4-1</a:t>
+              <a:t>Unit 3  ·  Lesson 3-2</a:t>
             </a:r>
             <a:endParaRPr lang="en-US" sz="1000" dirty="0"/>
           </a:p>
@@ -2860,7 +2860,7 @@
             <a:r>
               <a:rPr lang="en-US" sz="1100" b="1" dirty="0">
                 <a:solidFill>
-                  <a:srgbClr val="B0883B"/>
+                  <a:srgbClr val="C0654A"/>
                 </a:solidFill>
                 <a:latin typeface="Outfit" pitchFamily="34" charset="0"/>
                 <a:ea typeface="Outfit" pitchFamily="34" charset="-122"/>
@@ -2919,7 +2919,7 @@
                 <a:ea typeface="Hanken Grotesk" pitchFamily="34" charset="-122"/>
                 <a:cs typeface="Hanken Grotesk" pitchFamily="34" charset="-120"/>
               </a:rPr>
-              <a:t>I can find a unit rate to compare prices and decide the better buy.</a:t>
+              <a:t>I can describe a rate using its two different units and use a model to find a travel time, and I can find a unit rate to compare prices and decide the better buy.</a:t>
             </a:r>
             <a:endParaRPr lang="en-US" sz="1100" dirty="0"/>
           </a:p>
@@ -2986,7 +2986,7 @@
             <a:r>
               <a:rPr lang="en-US" sz="1100" b="1" dirty="0">
                 <a:solidFill>
-                  <a:srgbClr val="B0883B"/>
+                  <a:srgbClr val="C0654A"/>
                 </a:solidFill>
                 <a:latin typeface="Outfit" pitchFamily="34" charset="0"/>
                 <a:ea typeface="Outfit" pitchFamily="34" charset="-122"/>
@@ -3045,7 +3045,7 @@
                 <a:ea typeface="Hanken Grotesk" pitchFamily="34" charset="-122"/>
                 <a:cs typeface="Hanken Grotesk" pitchFamily="34" charset="-120"/>
               </a:rPr>
-              <a:t>I can explain my choice using the words rate, unit rate, per, and better buy.</a:t>
+              <a:t>I can explain a rate like "150 miles per hour" using distance and time units, and explain my choice using the words rate, unit rate, per, and better buy.</a:t>
             </a:r>
             <a:endParaRPr lang="en-US" sz="1050" dirty="0"/>
           </a:p>
@@ -3198,7 +3198,7 @@
             </a:avLst>
           </a:prstGeom>
           <a:solidFill>
-            <a:srgbClr val="B0883B"/>
+            <a:srgbClr val="C0654A"/>
           </a:solidFill>
           <a:ln/>
         </p:spPr>
@@ -3437,7 +3437,7 @@
                 <a:ea typeface="Hanken Grotesk" pitchFamily="34" charset="-122"/>
                 <a:cs typeface="Hanken Grotesk" pitchFamily="34" charset="-120"/>
               </a:rPr>
-              <a:t>Reveal Math Grade 6  ·  Unit 4  ·  Lesson 4-1</a:t>
+              <a:t>Reveal Math Grade 6  ·  Unit 3  ·  Lesson 3-2</a:t>
             </a:r>
             <a:endParaRPr lang="en-US" sz="750" dirty="0"/>
           </a:p>
@@ -3803,7 +3803,7 @@
           </a:solidFill>
           <a:ln w="12700">
             <a:solidFill>
-              <a:srgbClr val="B0883B"/>
+              <a:srgbClr val="C0654A"/>
             </a:solidFill>
             <a:prstDash val="solid"/>
           </a:ln>
@@ -3831,7 +3831,7 @@
             <a:avLst/>
           </a:prstGeom>
           <a:solidFill>
-            <a:srgbClr val="B0883B"/>
+            <a:srgbClr val="C0654A"/>
           </a:solidFill>
           <a:ln/>
         </p:spPr>
@@ -3878,7 +3878,7 @@
           </a:solidFill>
           <a:ln w="12700">
             <a:solidFill>
-              <a:srgbClr val="B0883B"/>
+              <a:srgbClr val="C0654A"/>
             </a:solidFill>
             <a:prstDash val="solid"/>
           </a:ln>
@@ -3906,7 +3906,7 @@
             <a:avLst/>
           </a:prstGeom>
           <a:solidFill>
-            <a:srgbClr val="B0883B"/>
+            <a:srgbClr val="C0654A"/>
           </a:solidFill>
           <a:ln/>
         </p:spPr>
@@ -4308,7 +4308,7 @@
             </a:avLst>
           </a:prstGeom>
           <a:solidFill>
-            <a:srgbClr val="B0883B"/>
+            <a:srgbClr val="C0654A"/>
           </a:solidFill>
           <a:ln/>
         </p:spPr>
@@ -4547,7 +4547,7 @@
                 <a:ea typeface="Hanken Grotesk" pitchFamily="34" charset="-122"/>
                 <a:cs typeface="Hanken Grotesk" pitchFamily="34" charset="-120"/>
               </a:rPr>
-              <a:t>Reveal Math Grade 6  ·  Unit 4  ·  Lesson 4-1</a:t>
+              <a:t>Reveal Math Grade 6  ·  Unit 3  ·  Lesson 3-2</a:t>
             </a:r>
             <a:endParaRPr lang="en-US" sz="750" dirty="0"/>
           </a:p>
@@ -5577,7 +5577,7 @@
             </a:avLst>
           </a:prstGeom>
           <a:solidFill>
-            <a:srgbClr val="B0883B"/>
+            <a:srgbClr val="C0654A"/>
           </a:solidFill>
           <a:ln/>
         </p:spPr>
@@ -5816,7 +5816,7 @@
                 <a:ea typeface="Hanken Grotesk" pitchFamily="34" charset="-122"/>
                 <a:cs typeface="Hanken Grotesk" pitchFamily="34" charset="-120"/>
               </a:rPr>
-              <a:t>Reveal Math Grade 6  ·  Unit 4  ·  Lesson 4-1</a:t>
+              <a:t>Reveal Math Grade 6  ·  Unit 3  ·  Lesson 3-2</a:t>
             </a:r>
             <a:endParaRPr lang="en-US" sz="750" dirty="0"/>
           </a:p>
@@ -5951,7 +5951,7 @@
             <a:avLst/>
           </a:prstGeom>
           <a:solidFill>
-            <a:srgbClr val="B0883B"/>
+            <a:srgbClr val="C0654A"/>
           </a:solidFill>
           <a:ln/>
         </p:spPr>
@@ -6049,7 +6049,7 @@
             <a:avLst/>
           </a:prstGeom>
           <a:solidFill>
-            <a:srgbClr val="B0883B"/>
+            <a:srgbClr val="C0654A"/>
           </a:solidFill>
           <a:ln/>
         </p:spPr>
@@ -6147,7 +6147,7 @@
             <a:avLst/>
           </a:prstGeom>
           <a:solidFill>
-            <a:srgbClr val="B0883B"/>
+            <a:srgbClr val="C0654A"/>
           </a:solidFill>
           <a:ln/>
         </p:spPr>
@@ -6245,7 +6245,7 @@
             <a:avLst/>
           </a:prstGeom>
           <a:solidFill>
-            <a:srgbClr val="B0883B"/>
+            <a:srgbClr val="C0654A"/>
           </a:solidFill>
           <a:ln/>
         </p:spPr>
@@ -6322,7 +6322,7 @@
                 <a:ea typeface="Hanken Grotesk" pitchFamily="34" charset="-122"/>
                 <a:cs typeface="Hanken Grotesk" pitchFamily="34" charset="-120"/>
               </a:rPr>
-              <a:t>Now I can compare this booth fairly with any other booth.</a:t>
+              <a:t>Because this unit rate is money for one item, it has its own name: it is the unit price.</a:t>
             </a:r>
             <a:endParaRPr lang="en-US" sz="1050" dirty="0"/>
           </a:p>
@@ -6331,6 +6331,104 @@
       <p:sp>
         <p:nvSpPr>
           <p:cNvPr id="31" name="Shape 29"/>
+          <p:cNvSpPr/>
+          <p:nvPr/>
+        </p:nvSpPr>
+        <p:spPr>
+          <a:xfrm>
+            <a:off x="594360" y="3145536"/>
+            <a:ext cx="274320" cy="274320"/>
+          </a:xfrm>
+          <a:prstGeom prst="ellipse">
+            <a:avLst/>
+          </a:prstGeom>
+          <a:solidFill>
+            <a:srgbClr val="C0654A"/>
+          </a:solidFill>
+          <a:ln/>
+        </p:spPr>
+      </p:sp>
+      <p:sp>
+        <p:nvSpPr>
+          <p:cNvPr id="32" name="Text 30"/>
+          <p:cNvSpPr/>
+          <p:nvPr/>
+        </p:nvSpPr>
+        <p:spPr>
+          <a:xfrm>
+            <a:off x="594360" y="3145536"/>
+            <a:ext cx="274320" cy="274320"/>
+          </a:xfrm>
+          <a:prstGeom prst="rect">
+            <a:avLst/>
+          </a:prstGeom>
+          <a:noFill/>
+          <a:ln/>
+        </p:spPr>
+        <p:txBody>
+          <a:bodyPr wrap="square" rtlCol="0" anchor="ctr"/>
+          <a:lstStyle/>
+          <a:p>
+            <a:pPr algn="ctr" indent="0" marL="0">
+              <a:buNone/>
+            </a:pPr>
+            <a:r>
+              <a:rPr lang="en-US" sz="1100" b="1" dirty="0">
+                <a:solidFill>
+                  <a:srgbClr val="FFFFFF"/>
+                </a:solidFill>
+                <a:latin typeface="Outfit" pitchFamily="34" charset="0"/>
+                <a:ea typeface="Outfit" pitchFamily="34" charset="-122"/>
+                <a:cs typeface="Outfit" pitchFamily="34" charset="-120"/>
+              </a:rPr>
+              <a:t>5</a:t>
+            </a:r>
+            <a:endParaRPr lang="en-US" sz="1100" dirty="0"/>
+          </a:p>
+        </p:txBody>
+      </p:sp>
+      <p:sp>
+        <p:nvSpPr>
+          <p:cNvPr id="33" name="Text 31"/>
+          <p:cNvSpPr/>
+          <p:nvPr/>
+        </p:nvSpPr>
+        <p:spPr>
+          <a:xfrm>
+            <a:off x="978408" y="3090672"/>
+            <a:ext cx="3456432" cy="420624"/>
+          </a:xfrm>
+          <a:prstGeom prst="rect">
+            <a:avLst/>
+          </a:prstGeom>
+          <a:noFill/>
+          <a:ln/>
+        </p:spPr>
+        <p:txBody>
+          <a:bodyPr wrap="square" rtlCol="0" anchor="ctr"/>
+          <a:lstStyle/>
+          <a:p>
+            <a:pPr indent="0" marL="0">
+              <a:buNone/>
+            </a:pPr>
+            <a:r>
+              <a:rPr lang="en-US" sz="1050" dirty="0">
+                <a:solidFill>
+                  <a:srgbClr val="24323F"/>
+                </a:solidFill>
+                <a:latin typeface="Hanken Grotesk" pitchFamily="34" charset="0"/>
+                <a:ea typeface="Hanken Grotesk" pitchFamily="34" charset="-122"/>
+                <a:cs typeface="Hanken Grotesk" pitchFamily="34" charset="-120"/>
+              </a:rPr>
+              <a:t>Now I can compare this booth's unit price fairly with any other booth's.</a:t>
+            </a:r>
+            <a:endParaRPr lang="en-US" sz="1050" dirty="0"/>
+          </a:p>
+        </p:txBody>
+      </p:sp>
+      <p:sp>
+        <p:nvSpPr>
+          <p:cNvPr id="34" name="Shape 32"/>
           <p:cNvSpPr/>
           <p:nvPr/>
         </p:nvSpPr>
@@ -6364,7 +6462,7 @@
       </p:sp>
       <p:sp>
         <p:nvSpPr>
-          <p:cNvPr id="32" name="Text 30"/>
+          <p:cNvPr id="35" name="Text 33"/>
           <p:cNvSpPr/>
           <p:nvPr/>
         </p:nvSpPr>
@@ -6405,7 +6503,7 @@
       </p:sp>
       <p:sp>
         <p:nvSpPr>
-          <p:cNvPr id="33" name="Text 31"/>
+          <p:cNvPr id="36" name="Text 34"/>
           <p:cNvSpPr/>
           <p:nvPr/>
         </p:nvSpPr>
@@ -6444,7 +6542,7 @@
       </p:sp>
       <p:sp>
         <p:nvSpPr>
-          <p:cNvPr id="34" name="Shape 32"/>
+          <p:cNvPr id="37" name="Shape 35"/>
           <p:cNvSpPr/>
           <p:nvPr/>
         </p:nvSpPr>
@@ -6467,7 +6565,7 @@
       </p:sp>
       <p:sp>
         <p:nvSpPr>
-          <p:cNvPr id="35" name="Shape 33"/>
+          <p:cNvPr id="38" name="Shape 36"/>
           <p:cNvSpPr/>
           <p:nvPr/>
         </p:nvSpPr>
@@ -6490,7 +6588,7 @@
       </p:sp>
       <p:sp>
         <p:nvSpPr>
-          <p:cNvPr id="36" name="Shape 34"/>
+          <p:cNvPr id="39" name="Shape 37"/>
           <p:cNvSpPr/>
           <p:nvPr/>
         </p:nvSpPr>
@@ -6513,7 +6611,7 @@
       </p:sp>
       <p:sp>
         <p:nvSpPr>
-          <p:cNvPr id="37" name="Shape 35"/>
+          <p:cNvPr id="40" name="Shape 38"/>
           <p:cNvSpPr/>
           <p:nvPr/>
         </p:nvSpPr>
@@ -6536,7 +6634,7 @@
       </p:sp>
       <p:sp>
         <p:nvSpPr>
-          <p:cNvPr id="38" name="Shape 36"/>
+          <p:cNvPr id="41" name="Shape 39"/>
           <p:cNvSpPr/>
           <p:nvPr/>
         </p:nvSpPr>
@@ -6559,7 +6657,7 @@
       </p:sp>
       <p:sp>
         <p:nvSpPr>
-          <p:cNvPr id="39" name="Shape 37"/>
+          <p:cNvPr id="42" name="Shape 40"/>
           <p:cNvSpPr/>
           <p:nvPr/>
         </p:nvSpPr>
@@ -6582,7 +6680,7 @@
       </p:sp>
       <p:sp>
         <p:nvSpPr>
-          <p:cNvPr id="40" name="Shape 38"/>
+          <p:cNvPr id="43" name="Shape 41"/>
           <p:cNvSpPr/>
           <p:nvPr/>
         </p:nvSpPr>
@@ -6605,7 +6703,7 @@
       </p:sp>
       <p:sp>
         <p:nvSpPr>
-          <p:cNvPr id="41" name="Shape 39"/>
+          <p:cNvPr id="44" name="Shape 42"/>
           <p:cNvSpPr/>
           <p:nvPr/>
         </p:nvSpPr>
@@ -6773,7 +6871,7 @@
             </a:avLst>
           </a:prstGeom>
           <a:solidFill>
-            <a:srgbClr val="B0883B"/>
+            <a:srgbClr val="C0654A"/>
           </a:solidFill>
           <a:ln/>
         </p:spPr>
@@ -7012,7 +7110,7 @@
                 <a:ea typeface="Hanken Grotesk" pitchFamily="34" charset="-122"/>
                 <a:cs typeface="Hanken Grotesk" pitchFamily="34" charset="-120"/>
               </a:rPr>
-              <a:t>Reveal Math Grade 6  ·  Unit 4  ·  Lesson 4-1</a:t>
+              <a:t>Reveal Math Grade 6  ·  Unit 3  ·  Lesson 3-2</a:t>
             </a:r>
             <a:endParaRPr lang="en-US" sz="750" dirty="0"/>
           </a:p>
@@ -7238,7 +7336,7 @@
                 <a:ea typeface="Hanken Grotesk" pitchFamily="34" charset="-122"/>
                 <a:cs typeface="Hanken Grotesk" pitchFamily="34" charset="-120"/>
               </a:rPr>
-              <a:t>Sketch a model for today's problem. Label it using Rate and Unit Rate.</a:t>
+              <a:t>Sketch a model for today's problem. Label it using Rates and Unit Rates and Rate.</a:t>
             </a:r>
             <a:endParaRPr lang="en-US" sz="1000" dirty="0"/>
           </a:p>
@@ -7386,7 +7484,7 @@
                 <a:ea typeface="Hanken Grotesk" pitchFamily="34" charset="-122"/>
                 <a:cs typeface="Hanken Grotesk" pitchFamily="34" charset="-120"/>
               </a:rPr>
-              <a:t>In 2–3 sentences, explain "To find a unit rate, divide the total cost by the number of items. The lower cost per item is the better buy." in your own words.</a:t>
+              <a:t>In 2–3 sentences, explain "Rates &amp; Unit Rates. Formula: Unit Rate = (Total Quantity) ÷ (Number of Units). 1. Rate: A ratio comparing two quantities with different units (e.g. $12 for 3 lbs). 2. Unit Rate: A rate simplified to a denominator of 1 unit ($4 per 1 lb). 3. Divide numerator by denominator to compute the per-one amount" in your own words.</a:t>
             </a:r>
             <a:endParaRPr lang="en-US" sz="1000" dirty="0"/>
           </a:p>
@@ -7682,7 +7780,7 @@
                 <a:ea typeface="Hanken Grotesk" pitchFamily="34" charset="-122"/>
                 <a:cs typeface="Hanken Grotesk" pitchFamily="34" charset="-120"/>
               </a:rPr>
-              <a:t>Write your own problem that uses Rate, then solve it and make an answer key.</a:t>
+              <a:t>Write your own problem that uses Rates and Unit Rates, then solve it and make an answer key.</a:t>
             </a:r>
             <a:endParaRPr lang="en-US" sz="1000" dirty="0"/>
           </a:p>
@@ -7835,7 +7933,7 @@
             </a:avLst>
           </a:prstGeom>
           <a:solidFill>
-            <a:srgbClr val="B0883B"/>
+            <a:srgbClr val="C0654A"/>
           </a:solidFill>
           <a:ln/>
         </p:spPr>
@@ -8074,7 +8172,7 @@
                 <a:ea typeface="Hanken Grotesk" pitchFamily="34" charset="-122"/>
                 <a:cs typeface="Hanken Grotesk" pitchFamily="34" charset="-120"/>
               </a:rPr>
-              <a:t>Reveal Math Grade 6  ·  Unit 4  ·  Lesson 4-1</a:t>
+              <a:t>Reveal Math Grade 6  ·  Unit 3  ·  Lesson 3-2</a:t>
             </a:r>
             <a:endParaRPr lang="en-US" sz="750" dirty="0"/>
           </a:p>
@@ -8170,7 +8268,7 @@
             </a:avLst>
           </a:prstGeom>
           <a:solidFill>
-            <a:srgbClr val="B0883B"/>
+            <a:srgbClr val="C0654A"/>
           </a:solidFill>
           <a:ln/>
         </p:spPr>
@@ -8223,7 +8321,7 @@
             <a:r>
               <a:rPr lang="en-US" sz="1050" b="1" dirty="0">
                 <a:solidFill>
-                  <a:srgbClr val="B0883B"/>
+                  <a:srgbClr val="C0654A"/>
                 </a:solidFill>
                 <a:latin typeface="Hanken Grotesk" pitchFamily="34" charset="0"/>
                 <a:ea typeface="Hanken Grotesk" pitchFamily="34" charset="-122"/>
@@ -8243,7 +8341,7 @@
                 <a:ea typeface="Hanken Grotesk" pitchFamily="34" charset="-122"/>
                 <a:cs typeface="Hanken Grotesk" pitchFamily="34" charset="-120"/>
               </a:rPr>
-              <a:t>Which token pack from the table above is the best deal?</a:t>
+              <a:t>Token packs: Pack A is 20 tokens for $5.00, Pack B is 35 tokens for $7.00, and Pack C is 50 tokens for $12.50. Which pack is the best deal per token?</a:t>
             </a:r>
             <a:endParaRPr lang="en-US" sz="1050" dirty="0"/>
           </a:p>
@@ -8299,7 +8397,7 @@
             <a:r>
               <a:rPr lang="en-US" sz="1050" b="1" dirty="0">
                 <a:solidFill>
-                  <a:srgbClr val="B0883B"/>
+                  <a:srgbClr val="C0654A"/>
                 </a:solidFill>
                 <a:latin typeface="Hanken Grotesk" pitchFamily="34" charset="0"/>
                 <a:ea typeface="Hanken Grotesk" pitchFamily="34" charset="-122"/>
@@ -8375,7 +8473,7 @@
             <a:r>
               <a:rPr lang="en-US" sz="1050" b="1" dirty="0">
                 <a:solidFill>
-                  <a:srgbClr val="B0883B"/>
+                  <a:srgbClr val="C0654A"/>
                 </a:solidFill>
                 <a:latin typeface="Hanken Grotesk" pitchFamily="34" charset="0"/>
                 <a:ea typeface="Hanken Grotesk" pitchFamily="34" charset="-122"/>
@@ -8800,7 +8898,7 @@
             </a:avLst>
           </a:prstGeom>
           <a:solidFill>
-            <a:srgbClr val="B0883B"/>
+            <a:srgbClr val="C0654A"/>
           </a:solidFill>
           <a:ln/>
         </p:spPr>
@@ -9039,7 +9137,7 @@
                 <a:ea typeface="Hanken Grotesk" pitchFamily="34" charset="-122"/>
                 <a:cs typeface="Hanken Grotesk" pitchFamily="34" charset="-120"/>
               </a:rPr>
-              <a:t>Reveal Math Grade 6  ·  Unit 4  ·  Lesson 4-1</a:t>
+              <a:t>Reveal Math Grade 6  ·  Unit 3  ·  Lesson 3-2</a:t>
             </a:r>
             <a:endParaRPr lang="en-US" sz="750" dirty="0"/>
           </a:p>
@@ -9198,7 +9296,7 @@
             <a:r>
               <a:rPr lang="en-US" sz="1100" b="1" dirty="0">
                 <a:solidFill>
-                  <a:srgbClr val="B0883B"/>
+                  <a:srgbClr val="C0654A"/>
                 </a:solidFill>
                 <a:latin typeface="Outfit" pitchFamily="34" charset="0"/>
                 <a:ea typeface="Outfit" pitchFamily="34" charset="-122"/>
@@ -9243,7 +9341,7 @@
                 <a:ea typeface="Hanken Grotesk" pitchFamily="34" charset="-122"/>
                 <a:cs typeface="Hanken Grotesk" pitchFamily="34" charset="-120"/>
               </a:rPr>
-              <a:t>Today's key idea is "To find a unit rate, divide the total cost by the number of items. The lower cost per item is the better buy." — and it works because ___.</a:t>
+              <a:t>Today's key idea is "Rates &amp; Unit Rates. Formula: Unit Rate = (Total Quantity) ÷ (Number of Units). 1. Rate: A ratio comparing two quantities with different units (e.g. $12 for 3 lbs). 2. Unit Rate: A rate simplified to a denominator of 1 unit ($4 per 1 lb). 3. Divide numerator by denominator to compute the per-one amount" — and it works because ___.</a:t>
             </a:r>
             <a:endParaRPr lang="en-US" sz="1050" dirty="0"/>
           </a:p>
@@ -9347,7 +9445,7 @@
             <a:r>
               <a:rPr lang="en-US" sz="1100" b="1" dirty="0">
                 <a:solidFill>
-                  <a:srgbClr val="B0883B"/>
+                  <a:srgbClr val="C0654A"/>
                 </a:solidFill>
                 <a:latin typeface="Outfit" pitchFamily="34" charset="0"/>
                 <a:ea typeface="Outfit" pitchFamily="34" charset="-122"/>
@@ -9392,7 +9490,7 @@
                 <a:ea typeface="Hanken Grotesk" pitchFamily="34" charset="-122"/>
                 <a:cs typeface="Hanken Grotesk" pitchFamily="34" charset="-120"/>
               </a:rPr>
-              <a:t>Because Rate means ___, but a tricky part is ___, so I have to ___.</a:t>
+              <a:t>Because Rates and Unit Rates means ___, but a tricky part is ___, so I have to ___.</a:t>
             </a:r>
             <a:endParaRPr lang="en-US" sz="1050" dirty="0"/>
           </a:p>
@@ -9496,7 +9594,7 @@
             <a:r>
               <a:rPr lang="en-US" sz="1100" b="1" dirty="0">
                 <a:solidFill>
-                  <a:srgbClr val="B0883B"/>
+                  <a:srgbClr val="C0654A"/>
                 </a:solidFill>
                 <a:latin typeface="Outfit" pitchFamily="34" charset="0"/>
                 <a:ea typeface="Outfit" pitchFamily="34" charset="-122"/>
@@ -9541,7 +9639,7 @@
                 <a:ea typeface="Hanken Grotesk" pitchFamily="34" charset="-122"/>
                 <a:cs typeface="Hanken Grotesk" pitchFamily="34" charset="-120"/>
               </a:rPr>
-              <a:t>A common mistake with Rate is ___. It happens because ___, and the fix is ___.</a:t>
+              <a:t>A common mistake with Rates and Unit Rates is ___. It happens because ___, and the fix is ___.</a:t>
             </a:r>
             <a:endParaRPr lang="en-US" sz="1050" dirty="0"/>
           </a:p>
@@ -9717,7 +9815,7 @@
             </a:avLst>
           </a:prstGeom>
           <a:solidFill>
-            <a:srgbClr val="B0883B"/>
+            <a:srgbClr val="C0654A"/>
           </a:solidFill>
           <a:ln/>
         </p:spPr>
@@ -9956,7 +10054,7 @@
                 <a:ea typeface="Hanken Grotesk" pitchFamily="34" charset="-122"/>
                 <a:cs typeface="Hanken Grotesk" pitchFamily="34" charset="-120"/>
               </a:rPr>
-              <a:t>Reveal Math Grade 6  ·  Unit 4  ·  Lesson 4-1</a:t>
+              <a:t>Reveal Math Grade 6  ·  Unit 3  ·  Lesson 3-2</a:t>
             </a:r>
             <a:endParaRPr lang="en-US" sz="750" dirty="0"/>
           </a:p>
@@ -10394,7 +10492,7 @@
             <a:r>
               <a:rPr lang="en-US" sz="1050" b="1" dirty="0">
                 <a:solidFill>
-                  <a:srgbClr val="B0883B"/>
+                  <a:srgbClr val="C0654A"/>
                 </a:solidFill>
                 <a:latin typeface="Hanken Grotesk" pitchFamily="34" charset="0"/>
                 <a:ea typeface="Hanken Grotesk" pitchFamily="34" charset="-122"/>
@@ -10453,7 +10551,7 @@
                 <a:ea typeface="Hanken Grotesk" pitchFamily="34" charset="-122"/>
                 <a:cs typeface="Hanken Grotesk" pitchFamily="34" charset="-120"/>
               </a:rPr>
-              <a:t>A.  6 for $1.50 — $0.25 each</a:t>
+              <a:t>A.  10 for $2.80 — $0.28 each</a:t>
             </a:r>
             <a:endParaRPr lang="en-US" sz="1000" dirty="0"/>
           </a:p>
@@ -10492,7 +10590,7 @@
                 <a:ea typeface="Hanken Grotesk" pitchFamily="34" charset="-122"/>
                 <a:cs typeface="Hanken Grotesk" pitchFamily="34" charset="-120"/>
               </a:rPr>
-              <a:t>B.  10 for $2.80 — $0.28 each</a:t>
+              <a:t>B.  6 for $1.50 — $0.25 each</a:t>
             </a:r>
             <a:endParaRPr lang="en-US" sz="1000" dirty="0"/>
           </a:p>
@@ -10603,7 +10701,7 @@
             <a:r>
               <a:rPr lang="en-US" sz="1050" b="1" dirty="0">
                 <a:solidFill>
-                  <a:srgbClr val="B0883B"/>
+                  <a:srgbClr val="C0654A"/>
                 </a:solidFill>
                 <a:latin typeface="Hanken Grotesk" pitchFamily="34" charset="0"/>
                 <a:ea typeface="Hanken Grotesk" pitchFamily="34" charset="-122"/>
@@ -10845,7 +10943,7 @@
             </a:avLst>
           </a:prstGeom>
           <a:solidFill>
-            <a:srgbClr val="B0883B"/>
+            <a:srgbClr val="C0654A"/>
           </a:solidFill>
           <a:ln/>
         </p:spPr>
@@ -11084,7 +11182,7 @@
                 <a:ea typeface="Hanken Grotesk" pitchFamily="34" charset="-122"/>
                 <a:cs typeface="Hanken Grotesk" pitchFamily="34" charset="-120"/>
               </a:rPr>
-              <a:t>Reveal Math Grade 6  ·  Unit 4  ·  Lesson 4-1</a:t>
+              <a:t>Reveal Math Grade 6  ·  Unit 3  ·  Lesson 3-2</a:t>
             </a:r>
             <a:endParaRPr lang="en-US" sz="750" dirty="0"/>
           </a:p>
@@ -11198,7 +11296,7 @@
                 <a:ea typeface="Hanken Grotesk" pitchFamily="34" charset="-122"/>
                 <a:cs typeface="Hanken Grotesk" pitchFamily="34" charset="-120"/>
               </a:rPr>
-              <a:t>I can find a unit rate to compare prices and decide the better buy.</a:t>
+              <a:t>I can describe a rate using its two different units and use a model to find a travel time, and I can find a unit rate to compare prices and decide the better buy.</a:t>
             </a:r>
             <a:endParaRPr lang="en-US" sz="1100" dirty="0"/>
           </a:p>
@@ -11253,7 +11351,7 @@
             <a:avLst/>
           </a:prstGeom>
           <a:solidFill>
-            <a:srgbClr val="B0883B"/>
+            <a:srgbClr val="C0654A"/>
           </a:solidFill>
           <a:ln/>
         </p:spPr>
@@ -11463,7 +11561,7 @@
             <a:avLst/>
           </a:prstGeom>
           <a:solidFill>
-            <a:srgbClr val="B0883B"/>
+            <a:srgbClr val="C0654A"/>
           </a:solidFill>
           <a:ln/>
         </p:spPr>
@@ -11673,7 +11771,7 @@
             <a:avLst/>
           </a:prstGeom>
           <a:solidFill>
-            <a:srgbClr val="B0883B"/>
+            <a:srgbClr val="C0654A"/>
           </a:solidFill>
           <a:ln/>
         </p:spPr>
@@ -11883,7 +11981,7 @@
             <a:avLst/>
           </a:prstGeom>
           <a:solidFill>
-            <a:srgbClr val="B0883B"/>
+            <a:srgbClr val="C0654A"/>
           </a:solidFill>
           <a:ln/>
         </p:spPr>
@@ -12105,7 +12203,7 @@
             <a:r>
               <a:rPr lang="en-US" sz="1050" b="1" dirty="0">
                 <a:solidFill>
-                  <a:srgbClr val="B0883B"/>
+                  <a:srgbClr val="C0654A"/>
                 </a:solidFill>
                 <a:latin typeface="Hanken Grotesk" pitchFamily="34" charset="0"/>
                 <a:ea typeface="Hanken Grotesk" pitchFamily="34" charset="-122"/>
@@ -12278,7 +12376,7 @@
             </a:avLst>
           </a:prstGeom>
           <a:solidFill>
-            <a:srgbClr val="B0883B"/>
+            <a:srgbClr val="C0654A"/>
           </a:solidFill>
           <a:ln/>
         </p:spPr>
@@ -12517,7 +12615,7 @@
                 <a:ea typeface="Hanken Grotesk" pitchFamily="34" charset="-122"/>
                 <a:cs typeface="Hanken Grotesk" pitchFamily="34" charset="-120"/>
               </a:rPr>
-              <a:t>Reveal Math Grade 6  ·  Unit 4  ·  Lesson 4-1</a:t>
+              <a:t>Reveal Math Grade 6  ·  Unit 3  ·  Lesson 3-2</a:t>
             </a:r>
             <a:endParaRPr lang="en-US" sz="750" dirty="0"/>
           </a:p>
@@ -12652,7 +12750,7 @@
             </a:avLst>
           </a:prstGeom>
           <a:solidFill>
-            <a:srgbClr val="B0883B"/>
+            <a:srgbClr val="C0654A"/>
           </a:solidFill>
           <a:ln/>
         </p:spPr>
@@ -12705,7 +12803,7 @@
             <a:r>
               <a:rPr lang="en-US" sz="1300" b="1" dirty="0">
                 <a:solidFill>
-                  <a:srgbClr val="B0883B"/>
+                  <a:srgbClr val="C0654A"/>
                 </a:solidFill>
                 <a:latin typeface="Outfit" pitchFamily="34" charset="0"/>
                 <a:ea typeface="Outfit" pitchFamily="34" charset="-122"/>
@@ -12767,7 +12865,7 @@
                 <a:ea typeface="Hanken Grotesk" pitchFamily="34" charset="-122"/>
                 <a:cs typeface="Hanken Grotesk" pitchFamily="34" charset="-120"/>
               </a:rPr>
-              <a:t>I can find a unit rate to compare prices and decide the better buy.</a:t>
+              <a:t>I can describe a rate using its two different units and use a model to find a travel time, and I can find a unit rate to compare prices and decide the better buy.</a:t>
             </a:r>
             <a:endParaRPr lang="en-US" sz="1800" dirty="0"/>
           </a:p>
@@ -12824,7 +12922,7 @@
             </a:avLst>
           </a:prstGeom>
           <a:solidFill>
-            <a:srgbClr val="B0883B"/>
+            <a:srgbClr val="C0654A"/>
           </a:solidFill>
           <a:ln/>
         </p:spPr>
@@ -12877,7 +12975,7 @@
             <a:r>
               <a:rPr lang="en-US" sz="1300" b="1" dirty="0">
                 <a:solidFill>
-                  <a:srgbClr val="B0883B"/>
+                  <a:srgbClr val="C0654A"/>
                 </a:solidFill>
                 <a:latin typeface="Outfit" pitchFamily="34" charset="0"/>
                 <a:ea typeface="Outfit" pitchFamily="34" charset="-122"/>
@@ -12939,7 +13037,7 @@
                 <a:ea typeface="Hanken Grotesk" pitchFamily="34" charset="-122"/>
                 <a:cs typeface="Hanken Grotesk" pitchFamily="34" charset="-120"/>
               </a:rPr>
-              <a:t>I can explain my choice using the words rate, unit rate, per, and better buy.</a:t>
+              <a:t>I can explain a rate like "150 miles per hour" using distance and time units, and explain my choice using the words rate, unit rate, per, and better buy.</a:t>
             </a:r>
             <a:endParaRPr lang="en-US" sz="1700" dirty="0"/>
           </a:p>
@@ -13092,7 +13190,7 @@
             </a:avLst>
           </a:prstGeom>
           <a:solidFill>
-            <a:srgbClr val="B0883B"/>
+            <a:srgbClr val="C0654A"/>
           </a:solidFill>
           <a:ln/>
         </p:spPr>
@@ -13331,7 +13429,7 @@
                 <a:ea typeface="Hanken Grotesk" pitchFamily="34" charset="-122"/>
                 <a:cs typeface="Hanken Grotesk" pitchFamily="34" charset="-120"/>
               </a:rPr>
-              <a:t>Reveal Math Grade 6  ·  Unit 4  ·  Lesson 4-1</a:t>
+              <a:t>Reveal Math Grade 6  ·  Unit 3  ·  Lesson 3-2</a:t>
             </a:r>
             <a:endParaRPr lang="en-US" sz="750" dirty="0"/>
           </a:p>
@@ -13427,7 +13525,7 @@
             </a:avLst>
           </a:prstGeom>
           <a:solidFill>
-            <a:srgbClr val="B0883B"/>
+            <a:srgbClr val="C0654A"/>
           </a:solidFill>
           <a:ln/>
         </p:spPr>
@@ -14152,7 +14250,7 @@
             </a:avLst>
           </a:prstGeom>
           <a:solidFill>
-            <a:srgbClr val="B0883B"/>
+            <a:srgbClr val="C0654A"/>
           </a:solidFill>
           <a:ln/>
         </p:spPr>
@@ -14391,7 +14489,7 @@
                 <a:ea typeface="Hanken Grotesk" pitchFamily="34" charset="-122"/>
                 <a:cs typeface="Hanken Grotesk" pitchFamily="34" charset="-120"/>
               </a:rPr>
-              <a:t>Reveal Math Grade 6  ·  Unit 4  ·  Lesson 4-1</a:t>
+              <a:t>Reveal Math Grade 6  ·  Unit 3  ·  Lesson 3-2</a:t>
             </a:r>
             <a:endParaRPr lang="en-US" sz="750" dirty="0"/>
           </a:p>
@@ -14487,7 +14585,7 @@
             </a:avLst>
           </a:prstGeom>
           <a:solidFill>
-            <a:srgbClr val="B0883B"/>
+            <a:srgbClr val="C0654A"/>
           </a:solidFill>
           <a:ln/>
         </p:spPr>
@@ -15259,7 +15357,7 @@
             </a:avLst>
           </a:prstGeom>
           <a:solidFill>
-            <a:srgbClr val="B0883B"/>
+            <a:srgbClr val="C0654A"/>
           </a:solidFill>
           <a:ln/>
         </p:spPr>
@@ -15498,7 +15596,7 @@
                 <a:ea typeface="Hanken Grotesk" pitchFamily="34" charset="-122"/>
                 <a:cs typeface="Hanken Grotesk" pitchFamily="34" charset="-120"/>
               </a:rPr>
-              <a:t>Reveal Math Grade 6  ·  Unit 4  ·  Lesson 4-1</a:t>
+              <a:t>Reveal Math Grade 6  ·  Unit 3  ·  Lesson 3-2</a:t>
             </a:r>
             <a:endParaRPr lang="en-US" sz="750" dirty="0"/>
           </a:p>
@@ -15594,7 +15692,7 @@
             </a:avLst>
           </a:prstGeom>
           <a:solidFill>
-            <a:srgbClr val="B0883B"/>
+            <a:srgbClr val="C0654A"/>
           </a:solidFill>
           <a:ln/>
         </p:spPr>
@@ -16366,7 +16464,7 @@
             </a:avLst>
           </a:prstGeom>
           <a:solidFill>
-            <a:srgbClr val="B0883B"/>
+            <a:srgbClr val="C0654A"/>
           </a:solidFill>
           <a:ln/>
         </p:spPr>
@@ -16605,7 +16703,7 @@
                 <a:ea typeface="Hanken Grotesk" pitchFamily="34" charset="-122"/>
                 <a:cs typeface="Hanken Grotesk" pitchFamily="34" charset="-120"/>
               </a:rPr>
-              <a:t>Reveal Math Grade 6  ·  Unit 4  ·  Lesson 4-1</a:t>
+              <a:t>Reveal Math Grade 6  ·  Unit 3  ·  Lesson 3-2</a:t>
             </a:r>
             <a:endParaRPr lang="en-US" sz="750" dirty="0"/>
           </a:p>
@@ -16701,7 +16799,7 @@
             </a:avLst>
           </a:prstGeom>
           <a:solidFill>
-            <a:srgbClr val="B0883B"/>
+            <a:srgbClr val="C0654A"/>
           </a:solidFill>
           <a:ln/>
         </p:spPr>
@@ -17426,7 +17524,7 @@
             </a:avLst>
           </a:prstGeom>
           <a:solidFill>
-            <a:srgbClr val="B0883B"/>
+            <a:srgbClr val="C0654A"/>
           </a:solidFill>
           <a:ln/>
         </p:spPr>
@@ -17665,7 +17763,7 @@
                 <a:ea typeface="Hanken Grotesk" pitchFamily="34" charset="-122"/>
                 <a:cs typeface="Hanken Grotesk" pitchFamily="34" charset="-120"/>
               </a:rPr>
-              <a:t>Reveal Math Grade 6  ·  Unit 4  ·  Lesson 4-1</a:t>
+              <a:t>Reveal Math Grade 6  ·  Unit 3  ·  Lesson 3-2</a:t>
             </a:r>
             <a:endParaRPr lang="en-US" sz="750" dirty="0"/>
           </a:p>
@@ -17761,7 +17859,7 @@
             </a:avLst>
           </a:prstGeom>
           <a:solidFill>
-            <a:srgbClr val="B0883B"/>
+            <a:srgbClr val="C0654A"/>
           </a:solidFill>
           <a:ln/>
         </p:spPr>
@@ -18394,7 +18492,7 @@
             </a:avLst>
           </a:prstGeom>
           <a:solidFill>
-            <a:srgbClr val="B0883B"/>
+            <a:srgbClr val="C0654A"/>
           </a:solidFill>
           <a:ln/>
         </p:spPr>
@@ -18633,7 +18731,7 @@
                 <a:ea typeface="Hanken Grotesk" pitchFamily="34" charset="-122"/>
                 <a:cs typeface="Hanken Grotesk" pitchFamily="34" charset="-120"/>
               </a:rPr>
-              <a:t>Reveal Math Grade 6  ·  Unit 4  ·  Lesson 4-1</a:t>
+              <a:t>Reveal Math Grade 6  ·  Unit 3  ·  Lesson 3-2</a:t>
             </a:r>
             <a:endParaRPr lang="en-US" sz="750" dirty="0"/>
           </a:p>
@@ -18929,6 +19027,260 @@
                           <a:ea typeface="Hanken Grotesk" pitchFamily="34" charset="-122"/>
                           <a:cs typeface="Hanken Grotesk" pitchFamily="34" charset="-120"/>
                         </a:rPr>
+                        <a:t>Rates and Unit Rates</a:t>
+                      </a:r>
+                      <a:pPr indent="0" marL="0">
+                        <a:buNone/>
+                      </a:pPr>
+                      <a:endParaRPr lang="en-US" sz="950" dirty="0">
+                        <a:latin typeface="Hanken Grotesk" charset="0"/>
+                        <a:ea typeface="Hanken Grotesk" charset="0"/>
+                        <a:cs typeface="Hanken Grotesk" charset="0"/>
+                      </a:endParaRPr>
+                    </a:p>
+                    <a:p>
+                      <a:pPr indent="0" marL="0">
+                        <a:buNone/>
+                      </a:pPr>
+                      <a:r>
+                        <a:rPr lang="en-US" sz="850" i="1" dirty="0">
+                          <a:solidFill>
+                            <a:srgbClr val="8A96A3"/>
+                          </a:solidFill>
+                          <a:latin typeface="Hanken Grotesk" pitchFamily="34" charset="0"/>
+                          <a:ea typeface="Hanken Grotesk" pitchFamily="34" charset="-122"/>
+                          <a:cs typeface="Hanken Grotesk" pitchFamily="34" charset="-120"/>
+                        </a:rPr>
+                        <a:t>Tasas y tasas unitarias</a:t>
+                      </a:r>
+                      <a:endParaRPr lang="en-US" sz="950" dirty="0">
+                        <a:latin typeface="Hanken Grotesk" charset="0"/>
+                        <a:ea typeface="Hanken Grotesk" charset="0"/>
+                        <a:cs typeface="Hanken Grotesk" charset="0"/>
+                      </a:endParaRPr>
+                    </a:p>
+                  </a:txBody>
+                  <a:tcPr marL="91440" marR="91440" marT="45720" marB="45720" anchor="ctr">
+                    <a:lnL w="9525" cap="flat" cmpd="sng" algn="ctr">
+                      <a:solidFill>
+                        <a:srgbClr val="D6DBDF"/>
+                      </a:solidFill>
+                      <a:prstDash val="solid"/>
+                      <a:round/>
+                      <a:headEnd type="none" w="med" len="med"/>
+                      <a:tailEnd type="none" w="med" len="med"/>
+                    </a:lnL>
+                    <a:lnR w="9525" cap="flat" cmpd="sng" algn="ctr">
+                      <a:solidFill>
+                        <a:srgbClr val="D6DBDF"/>
+                      </a:solidFill>
+                      <a:prstDash val="solid"/>
+                      <a:round/>
+                      <a:headEnd type="none" w="med" len="med"/>
+                      <a:tailEnd type="none" w="med" len="med"/>
+                    </a:lnR>
+                    <a:lnT w="9525" cap="flat" cmpd="sng" algn="ctr">
+                      <a:solidFill>
+                        <a:srgbClr val="D6DBDF"/>
+                      </a:solidFill>
+                      <a:prstDash val="solid"/>
+                      <a:round/>
+                      <a:headEnd type="none" w="med" len="med"/>
+                      <a:tailEnd type="none" w="med" len="med"/>
+                    </a:lnT>
+                    <a:lnB w="9525" cap="flat" cmpd="sng" algn="ctr">
+                      <a:solidFill>
+                        <a:srgbClr val="D6DBDF"/>
+                      </a:solidFill>
+                      <a:prstDash val="solid"/>
+                      <a:round/>
+                      <a:headEnd type="none" w="med" len="med"/>
+                      <a:tailEnd type="none" w="med" len="med"/>
+                    </a:lnB>
+                    <a:solidFill>
+                      <a:srgbClr val="FFFFFF"/>
+                    </a:solidFill>
+                  </a:tcPr>
+                </a:tc>
+                <a:tc>
+                  <a:txBody>
+                    <a:bodyPr/>
+                    <a:lstStyle/>
+                    <a:p>
+                      <a:pPr indent="0" marL="0">
+                        <a:buNone/>
+                      </a:pPr>
+                      <a:r>
+                        <a:rPr lang="en-US" sz="900" dirty="0">
+                          <a:solidFill>
+                            <a:srgbClr val="24323F"/>
+                          </a:solidFill>
+                          <a:latin typeface="Hanken Grotesk" pitchFamily="34" charset="0"/>
+                          <a:ea typeface="Hanken Grotesk" pitchFamily="34" charset="-122"/>
+                          <a:cs typeface="Hanken Grotesk" pitchFamily="34" charset="-120"/>
+                        </a:rPr>
+                        <a:t>A rate compares different units; a unit rate compares a quantity to 1 unit.</a:t>
+                      </a:r>
+                      <a:pPr indent="0" marL="0">
+                        <a:buNone/>
+                      </a:pPr>
+                      <a:endParaRPr lang="en-US" sz="900" dirty="0">
+                        <a:latin typeface="Hanken Grotesk" charset="0"/>
+                        <a:ea typeface="Hanken Grotesk" charset="0"/>
+                        <a:cs typeface="Hanken Grotesk" charset="0"/>
+                      </a:endParaRPr>
+                    </a:p>
+                    <a:p>
+                      <a:pPr indent="0" marL="0">
+                        <a:buNone/>
+                      </a:pPr>
+                      <a:r>
+                        <a:rPr lang="en-US" sz="850" i="1" dirty="0">
+                          <a:solidFill>
+                            <a:srgbClr val="8A96A3"/>
+                          </a:solidFill>
+                          <a:latin typeface="Hanken Grotesk" pitchFamily="34" charset="0"/>
+                          <a:ea typeface="Hanken Grotesk" pitchFamily="34" charset="-122"/>
+                          <a:cs typeface="Hanken Grotesk" pitchFamily="34" charset="-120"/>
+                        </a:rPr>
+                        <a:t>Una tasa compara unidades diferentes; una tasa unitaria compara una cantidad con 1 unidad.</a:t>
+                      </a:r>
+                      <a:endParaRPr lang="en-US" sz="900" dirty="0">
+                        <a:latin typeface="Hanken Grotesk" charset="0"/>
+                        <a:ea typeface="Hanken Grotesk" charset="0"/>
+                        <a:cs typeface="Hanken Grotesk" charset="0"/>
+                      </a:endParaRPr>
+                    </a:p>
+                  </a:txBody>
+                  <a:tcPr marL="91440" marR="91440" marT="45720" marB="45720" anchor="ctr">
+                    <a:lnL w="9525" cap="flat" cmpd="sng" algn="ctr">
+                      <a:solidFill>
+                        <a:srgbClr val="D6DBDF"/>
+                      </a:solidFill>
+                      <a:prstDash val="solid"/>
+                      <a:round/>
+                      <a:headEnd type="none" w="med" len="med"/>
+                      <a:tailEnd type="none" w="med" len="med"/>
+                    </a:lnL>
+                    <a:lnR w="9525" cap="flat" cmpd="sng" algn="ctr">
+                      <a:solidFill>
+                        <a:srgbClr val="D6DBDF"/>
+                      </a:solidFill>
+                      <a:prstDash val="solid"/>
+                      <a:round/>
+                      <a:headEnd type="none" w="med" len="med"/>
+                      <a:tailEnd type="none" w="med" len="med"/>
+                    </a:lnR>
+                    <a:lnT w="9525" cap="flat" cmpd="sng" algn="ctr">
+                      <a:solidFill>
+                        <a:srgbClr val="D6DBDF"/>
+                      </a:solidFill>
+                      <a:prstDash val="solid"/>
+                      <a:round/>
+                      <a:headEnd type="none" w="med" len="med"/>
+                      <a:tailEnd type="none" w="med" len="med"/>
+                    </a:lnT>
+                    <a:lnB w="9525" cap="flat" cmpd="sng" algn="ctr">
+                      <a:solidFill>
+                        <a:srgbClr val="D6DBDF"/>
+                      </a:solidFill>
+                      <a:prstDash val="solid"/>
+                      <a:round/>
+                      <a:headEnd type="none" w="med" len="med"/>
+                      <a:tailEnd type="none" w="med" len="med"/>
+                    </a:lnB>
+                    <a:solidFill>
+                      <a:srgbClr val="FFFFFF"/>
+                    </a:solidFill>
+                  </a:tcPr>
+                </a:tc>
+                <a:tc>
+                  <a:txBody>
+                    <a:bodyPr/>
+                    <a:lstStyle/>
+                    <a:p>
+                      <a:pPr indent="0" marL="0">
+                        <a:buNone/>
+                      </a:pPr>
+                      <a:r>
+                        <a:rPr lang="en-US" sz="900" i="1" dirty="0">
+                          <a:solidFill>
+                            <a:srgbClr val="24323F"/>
+                          </a:solidFill>
+                          <a:latin typeface="Hanken Grotesk" pitchFamily="34" charset="0"/>
+                          <a:ea typeface="Hanken Grotesk" pitchFamily="34" charset="-122"/>
+                          <a:cs typeface="Hanken Grotesk" pitchFamily="34" charset="-120"/>
+                        </a:rPr>
+                        <a:t>180 miles in 3 hours = 60 miles per 1 hour.</a:t>
+                      </a:r>
+                      <a:endParaRPr lang="en-US" sz="900" dirty="0">
+                        <a:latin typeface="Hanken Grotesk" charset="0"/>
+                        <a:ea typeface="Hanken Grotesk" charset="0"/>
+                        <a:cs typeface="Hanken Grotesk" charset="0"/>
+                      </a:endParaRPr>
+                    </a:p>
+                  </a:txBody>
+                  <a:tcPr marL="91440" marR="91440" marT="45720" marB="45720" anchor="ctr">
+                    <a:lnL w="9525" cap="flat" cmpd="sng" algn="ctr">
+                      <a:solidFill>
+                        <a:srgbClr val="D6DBDF"/>
+                      </a:solidFill>
+                      <a:prstDash val="solid"/>
+                      <a:round/>
+                      <a:headEnd type="none" w="med" len="med"/>
+                      <a:tailEnd type="none" w="med" len="med"/>
+                    </a:lnL>
+                    <a:lnR w="9525" cap="flat" cmpd="sng" algn="ctr">
+                      <a:solidFill>
+                        <a:srgbClr val="D6DBDF"/>
+                      </a:solidFill>
+                      <a:prstDash val="solid"/>
+                      <a:round/>
+                      <a:headEnd type="none" w="med" len="med"/>
+                      <a:tailEnd type="none" w="med" len="med"/>
+                    </a:lnR>
+                    <a:lnT w="9525" cap="flat" cmpd="sng" algn="ctr">
+                      <a:solidFill>
+                        <a:srgbClr val="D6DBDF"/>
+                      </a:solidFill>
+                      <a:prstDash val="solid"/>
+                      <a:round/>
+                      <a:headEnd type="none" w="med" len="med"/>
+                      <a:tailEnd type="none" w="med" len="med"/>
+                    </a:lnT>
+                    <a:lnB w="9525" cap="flat" cmpd="sng" algn="ctr">
+                      <a:solidFill>
+                        <a:srgbClr val="D6DBDF"/>
+                      </a:solidFill>
+                      <a:prstDash val="solid"/>
+                      <a:round/>
+                      <a:headEnd type="none" w="med" len="med"/>
+                      <a:tailEnd type="none" w="med" len="med"/>
+                    </a:lnB>
+                    <a:solidFill>
+                      <a:srgbClr val="FFFFFF"/>
+                    </a:solidFill>
+                  </a:tcPr>
+                </a:tc>
+              </a:tr>
+              <a:tr h="457200">
+                <a:tc>
+                  <a:txBody>
+                    <a:bodyPr/>
+                    <a:lstStyle/>
+                    <a:p>
+                      <a:pPr indent="0" marL="0">
+                        <a:buNone/>
+                      </a:pPr>
+                      <a:r>
+                        <a:rPr lang="en-US" sz="950" b="1" dirty="0">
+                          <a:solidFill>
+                            <a:srgbClr val="17324D"/>
+                          </a:solidFill>
+                          <a:latin typeface="Hanken Grotesk" pitchFamily="34" charset="0"/>
+                          <a:ea typeface="Hanken Grotesk" pitchFamily="34" charset="-122"/>
+                          <a:cs typeface="Hanken Grotesk" pitchFamily="34" charset="-120"/>
+                        </a:rPr>
                         <a:t>Rate</a:t>
                       </a:r>
                       <a:pPr indent="0" marL="0">
@@ -19000,7 +19352,7 @@
                       <a:tailEnd type="none" w="med" len="med"/>
                     </a:lnB>
                     <a:solidFill>
-                      <a:srgbClr val="FFFFFF"/>
+                      <a:srgbClr val="F4F1E8"/>
                     </a:solidFill>
                   </a:tcPr>
                 </a:tc>
@@ -19092,7 +19444,7 @@
                       <a:tailEnd type="none" w="med" len="med"/>
                     </a:lnB>
                     <a:solidFill>
-                      <a:srgbClr val="FFFFFF"/>
+                      <a:srgbClr val="F4F1E8"/>
                     </a:solidFill>
                   </a:tcPr>
                 </a:tc>
@@ -19160,7 +19512,7 @@
                       <a:tailEnd type="none" w="med" len="med"/>
                     </a:lnB>
                     <a:solidFill>
-                      <a:srgbClr val="FFFFFF"/>
+                      <a:srgbClr val="F4F1E8"/>
                     </a:solidFill>
                   </a:tcPr>
                 </a:tc>
@@ -19254,7 +19606,7 @@
                       <a:tailEnd type="none" w="med" len="med"/>
                     </a:lnB>
                     <a:solidFill>
-                      <a:srgbClr val="F4F1E8"/>
+                      <a:srgbClr val="FFFFFF"/>
                     </a:solidFill>
                   </a:tcPr>
                 </a:tc>
@@ -19346,7 +19698,7 @@
                       <a:tailEnd type="none" w="med" len="med"/>
                     </a:lnB>
                     <a:solidFill>
-                      <a:srgbClr val="F4F1E8"/>
+                      <a:srgbClr val="FFFFFF"/>
                     </a:solidFill>
                   </a:tcPr>
                 </a:tc>
@@ -19414,7 +19766,7 @@
                       <a:tailEnd type="none" w="med" len="med"/>
                     </a:lnB>
                     <a:solidFill>
-                      <a:srgbClr val="F4F1E8"/>
+                      <a:srgbClr val="FFFFFF"/>
                     </a:solidFill>
                   </a:tcPr>
                 </a:tc>
@@ -19508,7 +19860,7 @@
                       <a:tailEnd type="none" w="med" len="med"/>
                     </a:lnB>
                     <a:solidFill>
-                      <a:srgbClr val="FFFFFF"/>
+                      <a:srgbClr val="F4F1E8"/>
                     </a:solidFill>
                   </a:tcPr>
                 </a:tc>
@@ -19600,7 +19952,7 @@
                       <a:tailEnd type="none" w="med" len="med"/>
                     </a:lnB>
                     <a:solidFill>
-                      <a:srgbClr val="FFFFFF"/>
+                      <a:srgbClr val="F4F1E8"/>
                     </a:solidFill>
                   </a:tcPr>
                 </a:tc>
@@ -19668,7 +20020,7 @@
                       <a:tailEnd type="none" w="med" len="med"/>
                     </a:lnB>
                     <a:solidFill>
-                      <a:srgbClr val="FFFFFF"/>
+                      <a:srgbClr val="F4F1E8"/>
                     </a:solidFill>
                   </a:tcPr>
                 </a:tc>
@@ -19762,7 +20114,7 @@
                       <a:tailEnd type="none" w="med" len="med"/>
                     </a:lnB>
                     <a:solidFill>
-                      <a:srgbClr val="F4F1E8"/>
+                      <a:srgbClr val="FFFFFF"/>
                     </a:solidFill>
                   </a:tcPr>
                 </a:tc>
@@ -19783,7 +20135,7 @@
                           <a:ea typeface="Hanken Grotesk" pitchFamily="34" charset="-122"/>
                           <a:cs typeface="Hanken Grotesk" pitchFamily="34" charset="-120"/>
                         </a:rPr>
-                        <a:t>A way to compare two amounts.</a:t>
+                        <a:t>A way to compare two amounts, like 3 to 2.</a:t>
                       </a:r>
                       <a:pPr indent="0" marL="0">
                         <a:buNone/>
@@ -19807,7 +20159,7 @@
                           <a:ea typeface="Hanken Grotesk" pitchFamily="34" charset="-122"/>
                           <a:cs typeface="Hanken Grotesk" pitchFamily="34" charset="-120"/>
                         </a:rPr>
-                        <a:t>Una manera de comparar dos cantidades.</a:t>
+                        <a:t>Una manera de comparar dos cantidades, como 3 a 2.</a:t>
                       </a:r>
                       <a:endParaRPr lang="en-US" sz="900" dirty="0">
                         <a:latin typeface="Hanken Grotesk" charset="0"/>
@@ -19854,7 +20206,7 @@
                       <a:tailEnd type="none" w="med" len="med"/>
                     </a:lnB>
                     <a:solidFill>
-                      <a:srgbClr val="F4F1E8"/>
+                      <a:srgbClr val="FFFFFF"/>
                     </a:solidFill>
                   </a:tcPr>
                 </a:tc>
@@ -19922,260 +20274,6 @@
                       <a:tailEnd type="none" w="med" len="med"/>
                     </a:lnB>
                     <a:solidFill>
-                      <a:srgbClr val="F4F1E8"/>
-                    </a:solidFill>
-                  </a:tcPr>
-                </a:tc>
-              </a:tr>
-              <a:tr h="457200">
-                <a:tc>
-                  <a:txBody>
-                    <a:bodyPr/>
-                    <a:lstStyle/>
-                    <a:p>
-                      <a:pPr indent="0" marL="0">
-                        <a:buNone/>
-                      </a:pPr>
-                      <a:r>
-                        <a:rPr lang="en-US" sz="950" b="1" dirty="0">
-                          <a:solidFill>
-                            <a:srgbClr val="17324D"/>
-                          </a:solidFill>
-                          <a:latin typeface="Hanken Grotesk" pitchFamily="34" charset="0"/>
-                          <a:ea typeface="Hanken Grotesk" pitchFamily="34" charset="-122"/>
-                          <a:cs typeface="Hanken Grotesk" pitchFamily="34" charset="-120"/>
-                        </a:rPr>
-                        <a:t>Better Buy</a:t>
-                      </a:r>
-                      <a:pPr indent="0" marL="0">
-                        <a:buNone/>
-                      </a:pPr>
-                      <a:endParaRPr lang="en-US" sz="950" dirty="0">
-                        <a:latin typeface="Hanken Grotesk" charset="0"/>
-                        <a:ea typeface="Hanken Grotesk" charset="0"/>
-                        <a:cs typeface="Hanken Grotesk" charset="0"/>
-                      </a:endParaRPr>
-                    </a:p>
-                    <a:p>
-                      <a:pPr indent="0" marL="0">
-                        <a:buNone/>
-                      </a:pPr>
-                      <a:r>
-                        <a:rPr lang="en-US" sz="850" i="1" dirty="0">
-                          <a:solidFill>
-                            <a:srgbClr val="8A96A3"/>
-                          </a:solidFill>
-                          <a:latin typeface="Hanken Grotesk" pitchFamily="34" charset="0"/>
-                          <a:ea typeface="Hanken Grotesk" pitchFamily="34" charset="-122"/>
-                          <a:cs typeface="Hanken Grotesk" pitchFamily="34" charset="-120"/>
-                        </a:rPr>
-                        <a:t>Mejor compra</a:t>
-                      </a:r>
-                      <a:endParaRPr lang="en-US" sz="950" dirty="0">
-                        <a:latin typeface="Hanken Grotesk" charset="0"/>
-                        <a:ea typeface="Hanken Grotesk" charset="0"/>
-                        <a:cs typeface="Hanken Grotesk" charset="0"/>
-                      </a:endParaRPr>
-                    </a:p>
-                  </a:txBody>
-                  <a:tcPr marL="91440" marR="91440" marT="45720" marB="45720" anchor="ctr">
-                    <a:lnL w="9525" cap="flat" cmpd="sng" algn="ctr">
-                      <a:solidFill>
-                        <a:srgbClr val="D6DBDF"/>
-                      </a:solidFill>
-                      <a:prstDash val="solid"/>
-                      <a:round/>
-                      <a:headEnd type="none" w="med" len="med"/>
-                      <a:tailEnd type="none" w="med" len="med"/>
-                    </a:lnL>
-                    <a:lnR w="9525" cap="flat" cmpd="sng" algn="ctr">
-                      <a:solidFill>
-                        <a:srgbClr val="D6DBDF"/>
-                      </a:solidFill>
-                      <a:prstDash val="solid"/>
-                      <a:round/>
-                      <a:headEnd type="none" w="med" len="med"/>
-                      <a:tailEnd type="none" w="med" len="med"/>
-                    </a:lnR>
-                    <a:lnT w="9525" cap="flat" cmpd="sng" algn="ctr">
-                      <a:solidFill>
-                        <a:srgbClr val="D6DBDF"/>
-                      </a:solidFill>
-                      <a:prstDash val="solid"/>
-                      <a:round/>
-                      <a:headEnd type="none" w="med" len="med"/>
-                      <a:tailEnd type="none" w="med" len="med"/>
-                    </a:lnT>
-                    <a:lnB w="9525" cap="flat" cmpd="sng" algn="ctr">
-                      <a:solidFill>
-                        <a:srgbClr val="D6DBDF"/>
-                      </a:solidFill>
-                      <a:prstDash val="solid"/>
-                      <a:round/>
-                      <a:headEnd type="none" w="med" len="med"/>
-                      <a:tailEnd type="none" w="med" len="med"/>
-                    </a:lnB>
-                    <a:solidFill>
-                      <a:srgbClr val="FFFFFF"/>
-                    </a:solidFill>
-                  </a:tcPr>
-                </a:tc>
-                <a:tc>
-                  <a:txBody>
-                    <a:bodyPr/>
-                    <a:lstStyle/>
-                    <a:p>
-                      <a:pPr indent="0" marL="0">
-                        <a:buNone/>
-                      </a:pPr>
-                      <a:r>
-                        <a:rPr lang="en-US" sz="900" dirty="0">
-                          <a:solidFill>
-                            <a:srgbClr val="24323F"/>
-                          </a:solidFill>
-                          <a:latin typeface="Hanken Grotesk" pitchFamily="34" charset="0"/>
-                          <a:ea typeface="Hanken Grotesk" pitchFamily="34" charset="-122"/>
-                          <a:cs typeface="Hanken Grotesk" pitchFamily="34" charset="-120"/>
-                        </a:rPr>
-                        <a:t>The choice that costs less for each item.</a:t>
-                      </a:r>
-                      <a:pPr indent="0" marL="0">
-                        <a:buNone/>
-                      </a:pPr>
-                      <a:endParaRPr lang="en-US" sz="900" dirty="0">
-                        <a:latin typeface="Hanken Grotesk" charset="0"/>
-                        <a:ea typeface="Hanken Grotesk" charset="0"/>
-                        <a:cs typeface="Hanken Grotesk" charset="0"/>
-                      </a:endParaRPr>
-                    </a:p>
-                    <a:p>
-                      <a:pPr indent="0" marL="0">
-                        <a:buNone/>
-                      </a:pPr>
-                      <a:r>
-                        <a:rPr lang="en-US" sz="850" i="1" dirty="0">
-                          <a:solidFill>
-                            <a:srgbClr val="8A96A3"/>
-                          </a:solidFill>
-                          <a:latin typeface="Hanken Grotesk" pitchFamily="34" charset="0"/>
-                          <a:ea typeface="Hanken Grotesk" pitchFamily="34" charset="-122"/>
-                          <a:cs typeface="Hanken Grotesk" pitchFamily="34" charset="-120"/>
-                        </a:rPr>
-                        <a:t>La opción que cuesta menos por cada artículo.</a:t>
-                      </a:r>
-                      <a:endParaRPr lang="en-US" sz="900" dirty="0">
-                        <a:latin typeface="Hanken Grotesk" charset="0"/>
-                        <a:ea typeface="Hanken Grotesk" charset="0"/>
-                        <a:cs typeface="Hanken Grotesk" charset="0"/>
-                      </a:endParaRPr>
-                    </a:p>
-                  </a:txBody>
-                  <a:tcPr marL="91440" marR="91440" marT="45720" marB="45720" anchor="ctr">
-                    <a:lnL w="9525" cap="flat" cmpd="sng" algn="ctr">
-                      <a:solidFill>
-                        <a:srgbClr val="D6DBDF"/>
-                      </a:solidFill>
-                      <a:prstDash val="solid"/>
-                      <a:round/>
-                      <a:headEnd type="none" w="med" len="med"/>
-                      <a:tailEnd type="none" w="med" len="med"/>
-                    </a:lnL>
-                    <a:lnR w="9525" cap="flat" cmpd="sng" algn="ctr">
-                      <a:solidFill>
-                        <a:srgbClr val="D6DBDF"/>
-                      </a:solidFill>
-                      <a:prstDash val="solid"/>
-                      <a:round/>
-                      <a:headEnd type="none" w="med" len="med"/>
-                      <a:tailEnd type="none" w="med" len="med"/>
-                    </a:lnR>
-                    <a:lnT w="9525" cap="flat" cmpd="sng" algn="ctr">
-                      <a:solidFill>
-                        <a:srgbClr val="D6DBDF"/>
-                      </a:solidFill>
-                      <a:prstDash val="solid"/>
-                      <a:round/>
-                      <a:headEnd type="none" w="med" len="med"/>
-                      <a:tailEnd type="none" w="med" len="med"/>
-                    </a:lnT>
-                    <a:lnB w="9525" cap="flat" cmpd="sng" algn="ctr">
-                      <a:solidFill>
-                        <a:srgbClr val="D6DBDF"/>
-                      </a:solidFill>
-                      <a:prstDash val="solid"/>
-                      <a:round/>
-                      <a:headEnd type="none" w="med" len="med"/>
-                      <a:tailEnd type="none" w="med" len="med"/>
-                    </a:lnB>
-                    <a:solidFill>
-                      <a:srgbClr val="FFFFFF"/>
-                    </a:solidFill>
-                  </a:tcPr>
-                </a:tc>
-                <a:tc>
-                  <a:txBody>
-                    <a:bodyPr/>
-                    <a:lstStyle/>
-                    <a:p>
-                      <a:pPr indent="0" marL="0">
-                        <a:buNone/>
-                      </a:pPr>
-                      <a:r>
-                        <a:rPr lang="en-US" sz="900" i="1" dirty="0">
-                          <a:solidFill>
-                            <a:srgbClr val="24323F"/>
-                          </a:solidFill>
-                          <a:latin typeface="Hanken Grotesk" pitchFamily="34" charset="0"/>
-                          <a:ea typeface="Hanken Grotesk" pitchFamily="34" charset="-122"/>
-                          <a:cs typeface="Hanken Grotesk" pitchFamily="34" charset="-120"/>
-                        </a:rPr>
-                        <a:t>Pack A: $0.50 per pencil vs Pack B: $0.40 per pencil — Pack B is the better buy</a:t>
-                      </a:r>
-                      <a:endParaRPr lang="en-US" sz="900" dirty="0">
-                        <a:latin typeface="Hanken Grotesk" charset="0"/>
-                        <a:ea typeface="Hanken Grotesk" charset="0"/>
-                        <a:cs typeface="Hanken Grotesk" charset="0"/>
-                      </a:endParaRPr>
-                    </a:p>
-                  </a:txBody>
-                  <a:tcPr marL="91440" marR="91440" marT="45720" marB="45720" anchor="ctr">
-                    <a:lnL w="9525" cap="flat" cmpd="sng" algn="ctr">
-                      <a:solidFill>
-                        <a:srgbClr val="D6DBDF"/>
-                      </a:solidFill>
-                      <a:prstDash val="solid"/>
-                      <a:round/>
-                      <a:headEnd type="none" w="med" len="med"/>
-                      <a:tailEnd type="none" w="med" len="med"/>
-                    </a:lnL>
-                    <a:lnR w="9525" cap="flat" cmpd="sng" algn="ctr">
-                      <a:solidFill>
-                        <a:srgbClr val="D6DBDF"/>
-                      </a:solidFill>
-                      <a:prstDash val="solid"/>
-                      <a:round/>
-                      <a:headEnd type="none" w="med" len="med"/>
-                      <a:tailEnd type="none" w="med" len="med"/>
-                    </a:lnR>
-                    <a:lnT w="9525" cap="flat" cmpd="sng" algn="ctr">
-                      <a:solidFill>
-                        <a:srgbClr val="D6DBDF"/>
-                      </a:solidFill>
-                      <a:prstDash val="solid"/>
-                      <a:round/>
-                      <a:headEnd type="none" w="med" len="med"/>
-                      <a:tailEnd type="none" w="med" len="med"/>
-                    </a:lnT>
-                    <a:lnB w="9525" cap="flat" cmpd="sng" algn="ctr">
-                      <a:solidFill>
-                        <a:srgbClr val="D6DBDF"/>
-                      </a:solidFill>
-                      <a:prstDash val="solid"/>
-                      <a:round/>
-                      <a:headEnd type="none" w="med" len="med"/>
-                      <a:tailEnd type="none" w="med" len="med"/>
-                    </a:lnB>
-                    <a:solidFill>
                       <a:srgbClr val="FFFFFF"/>
                     </a:solidFill>
                   </a:tcPr>
@@ -20218,7 +20316,7 @@
                 <a:ea typeface="Outfit" pitchFamily="34" charset="-122"/>
                 <a:cs typeface="Outfit" pitchFamily="34" charset="-120"/>
               </a:rPr>
-              <a:t>Unit Rate — example vs. non-example:</a:t>
+              <a:t>Rates and Unit Rates — example vs. non-example:</a:t>
             </a:r>
             <a:endParaRPr lang="en-US" sz="950" dirty="0"/>
           </a:p>
@@ -20305,7 +20403,7 @@
                 <a:ea typeface="Hanken Grotesk" pitchFamily="34" charset="-122"/>
                 <a:cs typeface="Hanken Grotesk" pitchFamily="34" charset="-120"/>
               </a:rPr>
-              <a:t>$2 per 1 pound  </a:t>
+              <a:t>$0.75 per token  </a:t>
             </a:r>
             <a:pPr indent="0" marL="0">
               <a:buNone/>
@@ -20319,7 +20417,7 @@
                 <a:ea typeface="Hanken Grotesk" pitchFamily="34" charset="-122"/>
                 <a:cs typeface="Hanken Grotesk" pitchFamily="34" charset="-120"/>
               </a:rPr>
-              <a:t>It gives the amount for exactly one unit.</a:t>
+              <a:t>It gives the amount for one unit.</a:t>
             </a:r>
             <a:endParaRPr lang="en-US" sz="900" dirty="0"/>
           </a:p>
@@ -20406,7 +20504,7 @@
                 <a:ea typeface="Hanken Grotesk" pitchFamily="34" charset="-122"/>
                 <a:cs typeface="Hanken Grotesk" pitchFamily="34" charset="-120"/>
               </a:rPr>
-              <a:t>$6 for 3 pounds  </a:t>
+              <a:t>$9.00 for 12 tokens  </a:t>
             </a:r>
             <a:pPr indent="0" marL="0">
               <a:buNone/>
@@ -20420,7 +20518,7 @@
                 <a:ea typeface="Hanken Grotesk" pitchFamily="34" charset="-122"/>
                 <a:cs typeface="Hanken Grotesk" pitchFamily="34" charset="-120"/>
               </a:rPr>
-              <a:t>That is a rate for 3 units, not a unit rate.</a:t>
+              <a:t>A rate, but not yet per one.</a:t>
             </a:r>
             <a:endParaRPr lang="en-US" sz="900" dirty="0"/>
           </a:p>
@@ -20573,7 +20671,7 @@
             </a:avLst>
           </a:prstGeom>
           <a:solidFill>
-            <a:srgbClr val="B0883B"/>
+            <a:srgbClr val="C0654A"/>
           </a:solidFill>
           <a:ln/>
         </p:spPr>
@@ -20812,7 +20910,7 @@
                 <a:ea typeface="Hanken Grotesk" pitchFamily="34" charset="-122"/>
                 <a:cs typeface="Hanken Grotesk" pitchFamily="34" charset="-120"/>
               </a:rPr>
-              <a:t>Reveal Math Grade 6  ·  Unit 4  ·  Lesson 4-1</a:t>
+              <a:t>Reveal Math Grade 6  ·  Unit 3  ·  Lesson 3-2</a:t>
             </a:r>
             <a:endParaRPr lang="en-US" sz="750" dirty="0"/>
           </a:p>
@@ -20908,7 +21006,7 @@
             </a:avLst>
           </a:prstGeom>
           <a:solidFill>
-            <a:srgbClr val="B0883B"/>
+            <a:srgbClr val="C0654A"/>
           </a:solidFill>
           <a:ln/>
         </p:spPr>
@@ -20988,7 +21086,7 @@
             <a:avLst/>
           </a:prstGeom>
           <a:solidFill>
-            <a:srgbClr val="B0883B"/>
+            <a:srgbClr val="C0654A"/>
           </a:solidFill>
           <a:ln/>
         </p:spPr>
@@ -21086,7 +21184,7 @@
             <a:avLst/>
           </a:prstGeom>
           <a:solidFill>
-            <a:srgbClr val="B0883B"/>
+            <a:srgbClr val="C0654A"/>
           </a:solidFill>
           <a:ln/>
         </p:spPr>
@@ -21184,7 +21282,7 @@
             <a:avLst/>
           </a:prstGeom>
           <a:solidFill>
-            <a:srgbClr val="B0883B"/>
+            <a:srgbClr val="C0654A"/>
           </a:solidFill>
           <a:ln/>
         </p:spPr>
@@ -21261,7 +21359,7 @@
                 <a:ea typeface="Hanken Grotesk" pitchFamily="34" charset="-122"/>
                 <a:cs typeface="Hanken Grotesk" pitchFamily="34" charset="-120"/>
               </a:rPr>
-              <a:t>What is the cost for just 1 game? ($0.50 per game.)</a:t>
+              <a:t>What is the unit price, the cost for just 1 game? ($0.50 per game.)</a:t>
             </a:r>
             <a:endParaRPr lang="en-US" sz="1050" dirty="0"/>
           </a:p>
@@ -21504,7 +21602,7 @@
             <a:r>
               <a:rPr lang="en-US" sz="950" b="1" dirty="0">
                 <a:solidFill>
-                  <a:srgbClr val="B0883B"/>
+                  <a:srgbClr val="C0654A"/>
                 </a:solidFill>
                 <a:latin typeface="Outfit" pitchFamily="34" charset="0"/>
                 <a:ea typeface="Outfit" pitchFamily="34" charset="-122"/>
@@ -21549,7 +21647,7 @@
                 <a:ea typeface="Hanken Grotesk" pitchFamily="34" charset="-122"/>
                 <a:cs typeface="Hanken Grotesk" pitchFamily="34" charset="-120"/>
               </a:rPr>
-              <a:t>To find a unit rate, divide the total cost by the number of items. The lower cost per item is the better buy.</a:t>
+              <a:t>Rates &amp; Unit Rates. Formula: Unit Rate = (Total Quantity) ÷ (Number of Units). 1. Rate: A ratio comparing two quantities with different units (e.g. $12 for 3 lbs). 2. Unit Rate: A rate simplified to a denominator of 1 unit ($4 per 1 lb). 3. Divide numerator by denominator to compute the per-one amount</a:t>
             </a:r>
             <a:endParaRPr lang="en-US" sz="950" dirty="0"/>
           </a:p>

</xml_diff>